<commit_message>
Remove the load-testing findings slide from the presentation
Drops slide 10 ("What the numbers tell us") — the deck now goes from the
load-testing charts straight to the closing slide. 10 slides total.
</commit_message>
<xml_diff>
--- a/presentation/WAT4-React-Quiz-Testing.pptx
+++ b/presentation/WAT4-React-Quiz-Testing.pptx
@@ -14,7 +14,6 @@
     <p:sldId id="262" r:id="rId8"/>
     <p:sldId id="263" r:id="rId9"/>
     <p:sldId id="264" r:id="rId10"/>
-    <p:sldId id="265" r:id="rId11"/>
     <p:sldId id="266" r:id="rId12"/>
   </p:sldIdLst>
   <p:notesMasterIdLst>
@@ -1140,94 +1139,6 @@
             <a:fld id="{F7021451-1387-4CA6-816F-3879F97B5CBC}" type="slidenum">
               <a:rPr lang="en-US"/>
               <a:t>1</a:t>
-            </a:fld>
-            <a:endParaRPr lang="en-US"/>
-          </a:p>
-        </p:txBody>
-      </p:sp>
-    </p:spTree>
-    <p:extLst>
-      <p:ext uri="{BB962C8B-B14F-4D97-AF65-F5344CB8AC3E}">
-        <p14:creationId xmlns:p14="http://schemas.microsoft.com/office/powerpoint/2010/main" val="1024086991"/>
-      </p:ext>
-    </p:extLst>
-  </p:cSld>
-  <p:clrMapOvr>
-    <a:masterClrMapping/>
-  </p:clrMapOvr>
-</p:notes>
-</file>
-
-<file path=ppt/notesSlides/notesSlide10.xml><?xml version="1.0" encoding="utf-8"?>
-<p:notes xmlns:a="http://schemas.openxmlformats.org/drawingml/2006/main" xmlns:r="http://schemas.openxmlformats.org/officeDocument/2006/relationships" xmlns:p="http://schemas.openxmlformats.org/presentationml/2006/main">
-  <p:cSld>
-    <p:spTree>
-      <p:nvGrpSpPr>
-        <p:cNvPr id="1" name=""/>
-        <p:cNvGrpSpPr/>
-        <p:nvPr/>
-      </p:nvGrpSpPr>
-      <p:grpSpPr>
-        <a:xfrm>
-          <a:off x="0" y="0"/>
-          <a:ext cx="0" cy="0"/>
-          <a:chOff x="0" y="0"/>
-          <a:chExt cx="0" cy="0"/>
-        </a:xfrm>
-      </p:grpSpPr>
-      <p:sp>
-        <p:nvSpPr>
-          <p:cNvPr id="2" name="Slide Image Placeholder 1"/>
-          <p:cNvSpPr>
-            <a:spLocks noGrp="1" noRot="1" noChangeAspect="1"/>
-          </p:cNvSpPr>
-          <p:nvPr>
-            <p:ph type="sldImg"/>
-          </p:nvPr>
-        </p:nvSpPr>
-        <p:spPr/>
-      </p:sp>
-      <p:sp>
-        <p:nvSpPr>
-          <p:cNvPr id="3" name="Notes Placeholder 2"/>
-          <p:cNvSpPr>
-            <a:spLocks noGrp="1"/>
-          </p:cNvSpPr>
-          <p:nvPr>
-            <p:ph type="body" idx="1"/>
-          </p:nvPr>
-        </p:nvSpPr>
-        <p:spPr/>
-        <p:txBody>
-          <a:bodyPr/>
-          <a:lstStyle/>
-          <a:p>
-            <a:r>
-              <a:rPr lang="en-US" dirty="0"/>
-              <a:t/>
-            </a:r>
-            <a:endParaRPr lang="en-US" dirty="0"/>
-          </a:p>
-        </p:txBody>
-      </p:sp>
-      <p:sp>
-        <p:nvSpPr>
-          <p:cNvPr id="4" name="Slide Number Placeholder 3"/>
-          <p:cNvSpPr>
-            <a:spLocks noGrp="1"/>
-          </p:cNvSpPr>
-          <p:nvPr>
-            <p:ph type="sldNum" sz="quarter" idx="10"/>
-          </p:nvPr>
-        </p:nvSpPr>
-        <p:spPr/>
-        <p:txBody>
-          <a:bodyPr/>
-          <a:lstStyle/>
-          <a:p>
-            <a:fld id="{F7021451-1387-4CA6-816F-3879F97B5CBC}" type="slidenum">
-              <a:rPr lang="en-US"/>
-              <a:t>10</a:t>
             </a:fld>
             <a:endParaRPr lang="en-US"/>
           </a:p>
@@ -2577,7 +2488,7 @@
                 <a:ea typeface="Calibri" pitchFamily="34" charset="-122"/>
                 <a:cs typeface="Calibri" pitchFamily="34" charset="-120"/>
               </a:rPr>
-              <a:t>   ·   </a:t>
+              <a:t xml:space="preserve">   ·   </a:t>
             </a:r>
             <a:pPr indent="0" marL="0">
               <a:buNone/>
@@ -2605,7 +2516,7 @@
                 <a:ea typeface="Calibri" pitchFamily="34" charset="-122"/>
                 <a:cs typeface="Calibri" pitchFamily="34" charset="-120"/>
               </a:rPr>
-              <a:t>   ·   </a:t>
+              <a:t xml:space="preserve">   ·   </a:t>
             </a:r>
             <a:pPr indent="0" marL="0">
               <a:buNone/>
@@ -2661,712 +2572,6 @@
               <a:t>Forked from github.com/VINAYAK9669/React-QuizApp</a:t>
             </a:r>
             <a:endParaRPr lang="en-US" sz="1200" dirty="0"/>
-          </a:p>
-        </p:txBody>
-      </p:sp>
-    </p:spTree>
-  </p:cSld>
-  <p:clrMapOvr>
-    <a:masterClrMapping/>
-  </p:clrMapOvr>
-</p:sld>
-</file>
-
-<file path=ppt/slides/slide10.xml><?xml version="1.0" encoding="utf-8"?>
-<p:sld xmlns:a="http://schemas.openxmlformats.org/drawingml/2006/main" xmlns:r="http://schemas.openxmlformats.org/officeDocument/2006/relationships" xmlns:p="http://schemas.openxmlformats.org/presentationml/2006/main">
-  <p:cSld name="Slide 10">
-    <p:bg>
-      <p:bgPr>
-        <a:solidFill>
-          <a:srgbClr val="FFFFFF"/>
-        </a:solidFill>
-      </p:bgPr>
-    </p:bg>
-    <p:spTree>
-      <p:nvGrpSpPr>
-        <p:cNvPr id="1" name=""/>
-        <p:cNvGrpSpPr/>
-        <p:nvPr/>
-      </p:nvGrpSpPr>
-      <p:grpSpPr>
-        <a:xfrm>
-          <a:off x="0" y="0"/>
-          <a:ext cx="0" cy="0"/>
-          <a:chOff x="0" y="0"/>
-          <a:chExt cx="0" cy="0"/>
-        </a:xfrm>
-      </p:grpSpPr>
-      <p:sp>
-        <p:nvSpPr>
-          <p:cNvPr id="2" name="Text 0"/>
-          <p:cNvSpPr/>
-          <p:nvPr/>
-        </p:nvSpPr>
-        <p:spPr>
-          <a:xfrm>
-            <a:off x="548640" y="384048"/>
-            <a:ext cx="10972800" cy="274320"/>
-          </a:xfrm>
-          <a:prstGeom prst="rect">
-            <a:avLst/>
-          </a:prstGeom>
-          <a:noFill/>
-          <a:ln/>
-        </p:spPr>
-        <p:txBody>
-          <a:bodyPr wrap="square" lIns="0" tIns="0" rIns="0" bIns="0" rtlCol="0" anchor="ctr"/>
-          <a:lstStyle/>
-          <a:p>
-            <a:pPr indent="0" marL="0">
-              <a:buNone/>
-            </a:pPr>
-            <a:r>
-              <a:rPr lang="en-US" sz="1200" b="1" spc="200" kern="0" dirty="0">
-                <a:solidFill>
-                  <a:srgbClr val="028090"/>
-                </a:solidFill>
-                <a:latin typeface="Calibri" pitchFamily="34" charset="0"/>
-                <a:ea typeface="Calibri" pitchFamily="34" charset="-122"/>
-                <a:cs typeface="Calibri" pitchFamily="34" charset="-120"/>
-              </a:rPr>
-              <a:t>LOAD TESTING — FINDINGS</a:t>
-            </a:r>
-            <a:endParaRPr lang="en-US" sz="1200" dirty="0"/>
-          </a:p>
-        </p:txBody>
-      </p:sp>
-      <p:sp>
-        <p:nvSpPr>
-          <p:cNvPr id="3" name="Text 1"/>
-          <p:cNvSpPr/>
-          <p:nvPr/>
-        </p:nvSpPr>
-        <p:spPr>
-          <a:xfrm>
-            <a:off x="548640" y="658368"/>
-            <a:ext cx="11064240" cy="640080"/>
-          </a:xfrm>
-          <a:prstGeom prst="rect">
-            <a:avLst/>
-          </a:prstGeom>
-          <a:noFill/>
-          <a:ln/>
-        </p:spPr>
-        <p:txBody>
-          <a:bodyPr wrap="square" lIns="0" tIns="0" rIns="0" bIns="0" rtlCol="0" anchor="ctr"/>
-          <a:lstStyle/>
-          <a:p>
-            <a:pPr indent="0" marL="0">
-              <a:buNone/>
-            </a:pPr>
-            <a:r>
-              <a:rPr lang="en-US" sz="3000" b="1" dirty="0">
-                <a:solidFill>
-                  <a:srgbClr val="1E293B"/>
-                </a:solidFill>
-                <a:latin typeface="Cambria" pitchFamily="34" charset="0"/>
-                <a:ea typeface="Cambria" pitchFamily="34" charset="-122"/>
-                <a:cs typeface="Cambria" pitchFamily="34" charset="-120"/>
-              </a:rPr>
-              <a:t>What the numbers tell us</a:t>
-            </a:r>
-            <a:endParaRPr lang="en-US" sz="3000" dirty="0"/>
-          </a:p>
-        </p:txBody>
-      </p:sp>
-      <p:sp>
-        <p:nvSpPr>
-          <p:cNvPr id="4" name="Shape 2"/>
-          <p:cNvSpPr/>
-          <p:nvPr/>
-        </p:nvSpPr>
-        <p:spPr>
-          <a:xfrm>
-            <a:off x="548640" y="1691640"/>
-            <a:ext cx="6766560" cy="1097280"/>
-          </a:xfrm>
-          <a:prstGeom prst="roundRect">
-            <a:avLst>
-              <a:gd name="adj" fmla="val 6667"/>
-            </a:avLst>
-          </a:prstGeom>
-          <a:solidFill>
-            <a:srgbClr val="F1F5F7"/>
-          </a:solidFill>
-          <a:ln w="12700">
-            <a:solidFill>
-              <a:srgbClr val="E2E8F0"/>
-            </a:solidFill>
-            <a:prstDash val="solid"/>
-          </a:ln>
-          <a:effectLst>
-            <a:outerShdw sx="100000" sy="100000" kx="0" ky="0" algn="bl" rotWithShape="0" blurRad="88900" dist="38100" dir="5400000">
-              <a:srgbClr val="000000">
-                <a:alpha val="12000"/>
-              </a:srgbClr>
-            </a:outerShdw>
-          </a:effectLst>
-        </p:spPr>
-      </p:sp>
-      <p:sp>
-        <p:nvSpPr>
-          <p:cNvPr id="5" name="Shape 3"/>
-          <p:cNvSpPr/>
-          <p:nvPr/>
-        </p:nvSpPr>
-        <p:spPr>
-          <a:xfrm>
-            <a:off x="777240" y="2011680"/>
-            <a:ext cx="457200" cy="457200"/>
-          </a:xfrm>
-          <a:prstGeom prst="ellipse">
-            <a:avLst/>
-          </a:prstGeom>
-          <a:solidFill>
-            <a:srgbClr val="00A896"/>
-          </a:solidFill>
-          <a:ln/>
-        </p:spPr>
-      </p:sp>
-      <p:sp>
-        <p:nvSpPr>
-          <p:cNvPr id="6" name="Text 4"/>
-          <p:cNvSpPr/>
-          <p:nvPr/>
-        </p:nvSpPr>
-        <p:spPr>
-          <a:xfrm>
-            <a:off x="777240" y="2011680"/>
-            <a:ext cx="457200" cy="457200"/>
-          </a:xfrm>
-          <a:prstGeom prst="rect">
-            <a:avLst/>
-          </a:prstGeom>
-          <a:noFill/>
-          <a:ln/>
-        </p:spPr>
-        <p:txBody>
-          <a:bodyPr wrap="square" lIns="0" tIns="0" rIns="0" bIns="0" rtlCol="0" anchor="ctr"/>
-          <a:lstStyle/>
-          <a:p>
-            <a:pPr algn="ctr" indent="0" marL="0">
-              <a:buNone/>
-            </a:pPr>
-            <a:r>
-              <a:rPr lang="en-US" sz="1800" b="1" dirty="0">
-                <a:solidFill>
-                  <a:srgbClr val="FFFFFF"/>
-                </a:solidFill>
-                <a:latin typeface="Cambria" pitchFamily="34" charset="0"/>
-                <a:ea typeface="Cambria" pitchFamily="34" charset="-122"/>
-                <a:cs typeface="Cambria" pitchFamily="34" charset="-120"/>
-              </a:rPr>
-              <a:t>1</a:t>
-            </a:r>
-            <a:endParaRPr lang="en-US" sz="1800" dirty="0"/>
-          </a:p>
-        </p:txBody>
-      </p:sp>
-      <p:sp>
-        <p:nvSpPr>
-          <p:cNvPr id="7" name="Text 5"/>
-          <p:cNvSpPr/>
-          <p:nvPr/>
-        </p:nvSpPr>
-        <p:spPr>
-          <a:xfrm>
-            <a:off x="1417320" y="1691640"/>
-            <a:ext cx="5760720" cy="1097280"/>
-          </a:xfrm>
-          <a:prstGeom prst="rect">
-            <a:avLst/>
-          </a:prstGeom>
-          <a:noFill/>
-          <a:ln/>
-        </p:spPr>
-        <p:txBody>
-          <a:bodyPr wrap="square" lIns="0" tIns="0" rIns="0" bIns="0" rtlCol="0" anchor="ctr"/>
-          <a:lstStyle/>
-          <a:p>
-            <a:pPr indent="0" marL="0">
-              <a:buNone/>
-            </a:pPr>
-            <a:r>
-              <a:rPr lang="en-US" sz="1600" b="1" dirty="0">
-                <a:solidFill>
-                  <a:srgbClr val="1E293B"/>
-                </a:solidFill>
-                <a:latin typeface="Calibri" pitchFamily="34" charset="0"/>
-                <a:ea typeface="Calibri" pitchFamily="34" charset="-122"/>
-                <a:cs typeface="Calibri" pitchFamily="34" charset="-120"/>
-              </a:rPr>
-              <a:t>SLO met easily
-</a:t>
-            </a:r>
-            <a:pPr indent="0" marL="0">
-              <a:buNone/>
-            </a:pPr>
-            <a:r>
-              <a:rPr lang="en-US" sz="1300" dirty="0">
-                <a:solidFill>
-                  <a:srgbClr val="64748B"/>
-                </a:solidFill>
-                <a:latin typeface="Calibri" pitchFamily="34" charset="0"/>
-                <a:ea typeface="Calibri" pitchFamily="34" charset="-122"/>
-                <a:cs typeface="Calibri" pitchFamily="34" charset="-120"/>
-              </a:rPr>
-              <a:t>Under expected load: p95 ≈ 5 ms — two orders of magnitude under the 500 ms budget, 0 errors.</a:t>
-            </a:r>
-            <a:endParaRPr lang="en-US" sz="1600" dirty="0"/>
-          </a:p>
-        </p:txBody>
-      </p:sp>
-      <p:sp>
-        <p:nvSpPr>
-          <p:cNvPr id="8" name="Shape 6"/>
-          <p:cNvSpPr/>
-          <p:nvPr/>
-        </p:nvSpPr>
-        <p:spPr>
-          <a:xfrm>
-            <a:off x="548640" y="2926080"/>
-            <a:ext cx="6766560" cy="1097280"/>
-          </a:xfrm>
-          <a:prstGeom prst="roundRect">
-            <a:avLst>
-              <a:gd name="adj" fmla="val 6667"/>
-            </a:avLst>
-          </a:prstGeom>
-          <a:solidFill>
-            <a:srgbClr val="F1F5F7"/>
-          </a:solidFill>
-          <a:ln w="12700">
-            <a:solidFill>
-              <a:srgbClr val="E2E8F0"/>
-            </a:solidFill>
-            <a:prstDash val="solid"/>
-          </a:ln>
-          <a:effectLst>
-            <a:outerShdw sx="100000" sy="100000" kx="0" ky="0" algn="bl" rotWithShape="0" blurRad="88900" dist="38100" dir="5400000">
-              <a:srgbClr val="000000">
-                <a:alpha val="12000"/>
-              </a:srgbClr>
-            </a:outerShdw>
-          </a:effectLst>
-        </p:spPr>
-      </p:sp>
-      <p:sp>
-        <p:nvSpPr>
-          <p:cNvPr id="9" name="Shape 7"/>
-          <p:cNvSpPr/>
-          <p:nvPr/>
-        </p:nvSpPr>
-        <p:spPr>
-          <a:xfrm>
-            <a:off x="777240" y="3246120"/>
-            <a:ext cx="457200" cy="457200"/>
-          </a:xfrm>
-          <a:prstGeom prst="ellipse">
-            <a:avLst/>
-          </a:prstGeom>
-          <a:solidFill>
-            <a:srgbClr val="028090"/>
-          </a:solidFill>
-          <a:ln/>
-        </p:spPr>
-      </p:sp>
-      <p:sp>
-        <p:nvSpPr>
-          <p:cNvPr id="10" name="Text 8"/>
-          <p:cNvSpPr/>
-          <p:nvPr/>
-        </p:nvSpPr>
-        <p:spPr>
-          <a:xfrm>
-            <a:off x="777240" y="3246120"/>
-            <a:ext cx="457200" cy="457200"/>
-          </a:xfrm>
-          <a:prstGeom prst="rect">
-            <a:avLst/>
-          </a:prstGeom>
-          <a:noFill/>
-          <a:ln/>
-        </p:spPr>
-        <p:txBody>
-          <a:bodyPr wrap="square" lIns="0" tIns="0" rIns="0" bIns="0" rtlCol="0" anchor="ctr"/>
-          <a:lstStyle/>
-          <a:p>
-            <a:pPr algn="ctr" indent="0" marL="0">
-              <a:buNone/>
-            </a:pPr>
-            <a:r>
-              <a:rPr lang="en-US" sz="1800" b="1" dirty="0">
-                <a:solidFill>
-                  <a:srgbClr val="FFFFFF"/>
-                </a:solidFill>
-                <a:latin typeface="Cambria" pitchFamily="34" charset="0"/>
-                <a:ea typeface="Cambria" pitchFamily="34" charset="-122"/>
-                <a:cs typeface="Cambria" pitchFamily="34" charset="-120"/>
-              </a:rPr>
-              <a:t>2</a:t>
-            </a:r>
-            <a:endParaRPr lang="en-US" sz="1800" dirty="0"/>
-          </a:p>
-        </p:txBody>
-      </p:sp>
-      <p:sp>
-        <p:nvSpPr>
-          <p:cNvPr id="11" name="Text 9"/>
-          <p:cNvSpPr/>
-          <p:nvPr/>
-        </p:nvSpPr>
-        <p:spPr>
-          <a:xfrm>
-            <a:off x="1417320" y="2926080"/>
-            <a:ext cx="5760720" cy="1097280"/>
-          </a:xfrm>
-          <a:prstGeom prst="rect">
-            <a:avLst/>
-          </a:prstGeom>
-          <a:noFill/>
-          <a:ln/>
-        </p:spPr>
-        <p:txBody>
-          <a:bodyPr wrap="square" lIns="0" tIns="0" rIns="0" bIns="0" rtlCol="0" anchor="ctr"/>
-          <a:lstStyle/>
-          <a:p>
-            <a:pPr indent="0" marL="0">
-              <a:buNone/>
-            </a:pPr>
-            <a:r>
-              <a:rPr lang="en-US" sz="1600" b="1" dirty="0">
-                <a:solidFill>
-                  <a:srgbClr val="1E293B"/>
-                </a:solidFill>
-                <a:latin typeface="Calibri" pitchFamily="34" charset="0"/>
-                <a:ea typeface="Calibri" pitchFamily="34" charset="-122"/>
-                <a:cs typeface="Calibri" pitchFamily="34" charset="-120"/>
-              </a:rPr>
-              <a:t>Percentiles AND max matter
-</a:t>
-            </a:r>
-            <a:pPr indent="0" marL="0">
-              <a:buNone/>
-            </a:pPr>
-            <a:r>
-              <a:rPr lang="en-US" sz="1300" dirty="0">
-                <a:solidFill>
-                  <a:srgbClr val="64748B"/>
-                </a:solidFill>
-                <a:latin typeface="Calibri" pitchFamily="34" charset="0"/>
-                <a:ea typeface="Calibri" pitchFamily="34" charset="-122"/>
-                <a:cs typeface="Calibri" pitchFamily="34" charset="-120"/>
-              </a:rPr>
-              <a:t>During the spike, avg &amp; p95 stay ~3.8 ms, yet the max jumps to 580 ms — a connection-storm outlier invisible in the average.</a:t>
-            </a:r>
-            <a:endParaRPr lang="en-US" sz="1600" dirty="0"/>
-          </a:p>
-        </p:txBody>
-      </p:sp>
-      <p:sp>
-        <p:nvSpPr>
-          <p:cNvPr id="12" name="Shape 10"/>
-          <p:cNvSpPr/>
-          <p:nvPr/>
-        </p:nvSpPr>
-        <p:spPr>
-          <a:xfrm>
-            <a:off x="548640" y="4160520"/>
-            <a:ext cx="6766560" cy="1097280"/>
-          </a:xfrm>
-          <a:prstGeom prst="roundRect">
-            <a:avLst>
-              <a:gd name="adj" fmla="val 6667"/>
-            </a:avLst>
-          </a:prstGeom>
-          <a:solidFill>
-            <a:srgbClr val="F1F5F7"/>
-          </a:solidFill>
-          <a:ln w="12700">
-            <a:solidFill>
-              <a:srgbClr val="E2E8F0"/>
-            </a:solidFill>
-            <a:prstDash val="solid"/>
-          </a:ln>
-          <a:effectLst>
-            <a:outerShdw sx="100000" sy="100000" kx="0" ky="0" algn="bl" rotWithShape="0" blurRad="88900" dist="38100" dir="5400000">
-              <a:srgbClr val="000000">
-                <a:alpha val="12000"/>
-              </a:srgbClr>
-            </a:outerShdw>
-          </a:effectLst>
-        </p:spPr>
-      </p:sp>
-      <p:sp>
-        <p:nvSpPr>
-          <p:cNvPr id="13" name="Shape 11"/>
-          <p:cNvSpPr/>
-          <p:nvPr/>
-        </p:nvSpPr>
-        <p:spPr>
-          <a:xfrm>
-            <a:off x="777240" y="4480560"/>
-            <a:ext cx="457200" cy="457200"/>
-          </a:xfrm>
-          <a:prstGeom prst="ellipse">
-            <a:avLst/>
-          </a:prstGeom>
-          <a:solidFill>
-            <a:srgbClr val="0B3C49"/>
-          </a:solidFill>
-          <a:ln/>
-        </p:spPr>
-      </p:sp>
-      <p:sp>
-        <p:nvSpPr>
-          <p:cNvPr id="14" name="Text 12"/>
-          <p:cNvSpPr/>
-          <p:nvPr/>
-        </p:nvSpPr>
-        <p:spPr>
-          <a:xfrm>
-            <a:off x="777240" y="4480560"/>
-            <a:ext cx="457200" cy="457200"/>
-          </a:xfrm>
-          <a:prstGeom prst="rect">
-            <a:avLst/>
-          </a:prstGeom>
-          <a:noFill/>
-          <a:ln/>
-        </p:spPr>
-        <p:txBody>
-          <a:bodyPr wrap="square" lIns="0" tIns="0" rIns="0" bIns="0" rtlCol="0" anchor="ctr"/>
-          <a:lstStyle/>
-          <a:p>
-            <a:pPr algn="ctr" indent="0" marL="0">
-              <a:buNone/>
-            </a:pPr>
-            <a:r>
-              <a:rPr lang="en-US" sz="1800" b="1" dirty="0">
-                <a:solidFill>
-                  <a:srgbClr val="FFFFFF"/>
-                </a:solidFill>
-                <a:latin typeface="Cambria" pitchFamily="34" charset="0"/>
-                <a:ea typeface="Cambria" pitchFamily="34" charset="-122"/>
-                <a:cs typeface="Cambria" pitchFamily="34" charset="-120"/>
-              </a:rPr>
-              <a:t>3</a:t>
-            </a:r>
-            <a:endParaRPr lang="en-US" sz="1800" dirty="0"/>
-          </a:p>
-        </p:txBody>
-      </p:sp>
-      <p:sp>
-        <p:nvSpPr>
-          <p:cNvPr id="15" name="Text 13"/>
-          <p:cNvSpPr/>
-          <p:nvPr/>
-        </p:nvSpPr>
-        <p:spPr>
-          <a:xfrm>
-            <a:off x="1417320" y="4160520"/>
-            <a:ext cx="5760720" cy="1097280"/>
-          </a:xfrm>
-          <a:prstGeom prst="rect">
-            <a:avLst/>
-          </a:prstGeom>
-          <a:noFill/>
-          <a:ln/>
-        </p:spPr>
-        <p:txBody>
-          <a:bodyPr wrap="square" lIns="0" tIns="0" rIns="0" bIns="0" rtlCol="0" anchor="ctr"/>
-          <a:lstStyle/>
-          <a:p>
-            <a:pPr indent="0" marL="0">
-              <a:buNone/>
-            </a:pPr>
-            <a:r>
-              <a:rPr lang="en-US" sz="1600" b="1" dirty="0">
-                <a:solidFill>
-                  <a:srgbClr val="1E293B"/>
-                </a:solidFill>
-                <a:latin typeface="Calibri" pitchFamily="34" charset="0"/>
-                <a:ea typeface="Calibri" pitchFamily="34" charset="-122"/>
-                <a:cs typeface="Calibri" pitchFamily="34" charset="-120"/>
-              </a:rPr>
-              <a:t>No saturation reached
-</a:t>
-            </a:r>
-            <a:pPr indent="0" marL="0">
-              <a:buNone/>
-            </a:pPr>
-            <a:r>
-              <a:rPr lang="en-US" sz="1300" dirty="0">
-                <a:solidFill>
-                  <a:srgbClr val="64748B"/>
-                </a:solidFill>
-                <a:latin typeface="Calibri" pitchFamily="34" charset="0"/>
-                <a:ea typeface="Calibri" pitchFamily="34" charset="-122"/>
-                <a:cs typeface="Calibri" pitchFamily="34" charset="-120"/>
-              </a:rPr>
-              <a:t>Throughput scaled 20→200 req/s with flat latency: the small dataset is served very efficiently.</a:t>
-            </a:r>
-            <a:endParaRPr lang="en-US" sz="1600" dirty="0"/>
-          </a:p>
-        </p:txBody>
-      </p:sp>
-      <p:sp>
-        <p:nvSpPr>
-          <p:cNvPr id="16" name="Shape 14"/>
-          <p:cNvSpPr/>
-          <p:nvPr/>
-        </p:nvSpPr>
-        <p:spPr>
-          <a:xfrm>
-            <a:off x="7589520" y="1691640"/>
-            <a:ext cx="4023360" cy="3703320"/>
-          </a:xfrm>
-          <a:prstGeom prst="roundRect">
-            <a:avLst>
-              <a:gd name="adj" fmla="val 1975"/>
-            </a:avLst>
-          </a:prstGeom>
-          <a:solidFill>
-            <a:srgbClr val="0B3C49"/>
-          </a:solidFill>
-          <a:ln w="12700">
-            <a:solidFill>
-              <a:srgbClr val="E2E8F0"/>
-            </a:solidFill>
-            <a:prstDash val="solid"/>
-          </a:ln>
-          <a:effectLst>
-            <a:outerShdw sx="100000" sy="100000" kx="0" ky="0" algn="bl" rotWithShape="0" blurRad="88900" dist="38100" dir="5400000">
-              <a:srgbClr val="000000">
-                <a:alpha val="12000"/>
-              </a:srgbClr>
-            </a:outerShdw>
-          </a:effectLst>
-        </p:spPr>
-      </p:sp>
-      <p:sp>
-        <p:nvSpPr>
-          <p:cNvPr id="17" name="Text 15"/>
-          <p:cNvSpPr/>
-          <p:nvPr/>
-        </p:nvSpPr>
-        <p:spPr>
-          <a:xfrm>
-            <a:off x="7818120" y="1920240"/>
-            <a:ext cx="3657600" cy="365760"/>
-          </a:xfrm>
-          <a:prstGeom prst="rect">
-            <a:avLst/>
-          </a:prstGeom>
-          <a:noFill/>
-          <a:ln/>
-        </p:spPr>
-        <p:txBody>
-          <a:bodyPr wrap="square" lIns="0" tIns="0" rIns="0" bIns="0" rtlCol="0" anchor="ctr"/>
-          <a:lstStyle/>
-          <a:p>
-            <a:pPr indent="0" marL="0">
-              <a:buNone/>
-            </a:pPr>
-            <a:r>
-              <a:rPr lang="en-US" sz="1600" b="1" dirty="0">
-                <a:solidFill>
-                  <a:srgbClr val="02C39A"/>
-                </a:solidFill>
-                <a:latin typeface="Cambria" pitchFamily="34" charset="0"/>
-                <a:ea typeface="Cambria" pitchFamily="34" charset="-122"/>
-                <a:cs typeface="Cambria" pitchFamily="34" charset="-120"/>
-              </a:rPr>
-              <a:t>Bottleneck &amp; scaling</a:t>
-            </a:r>
-            <a:endParaRPr lang="en-US" sz="1600" dirty="0"/>
-          </a:p>
-        </p:txBody>
-      </p:sp>
-      <p:sp>
-        <p:nvSpPr>
-          <p:cNvPr id="18" name="Text 16"/>
-          <p:cNvSpPr/>
-          <p:nvPr/>
-        </p:nvSpPr>
-        <p:spPr>
-          <a:xfrm>
-            <a:off x="7818120" y="2423160"/>
-            <a:ext cx="3611880" cy="2834640"/>
-          </a:xfrm>
-          <a:prstGeom prst="rect">
-            <a:avLst/>
-          </a:prstGeom>
-          <a:noFill/>
-          <a:ln/>
-        </p:spPr>
-        <p:txBody>
-          <a:bodyPr wrap="square" lIns="0" tIns="0" rIns="0" bIns="0" rtlCol="0" anchor="t"/>
-          <a:lstStyle/>
-          <a:p>
-            <a:pPr indent="0" marL="0">
-              <a:spcAft>
-                <a:spcPts val="1400"/>
-              </a:spcAft>
-              <a:buNone/>
-            </a:pPr>
-            <a:r>
-              <a:rPr lang="en-US" sz="1450" dirty="0">
-                <a:solidFill>
-                  <a:srgbClr val="E6F2F4"/>
-                </a:solidFill>
-                <a:latin typeface="Calibri" pitchFamily="34" charset="0"/>
-                <a:ea typeface="Calibri" pitchFamily="34" charset="-122"/>
-                <a:cs typeface="Calibri" pitchFamily="34" charset="-120"/>
-              </a:rPr>
-              <a:t>The bottleneck is the single-threaded json-server, re-serving the data with no caching.</a:t>
-            </a:r>
-            <a:endParaRPr lang="en-US" sz="1450" dirty="0"/>
-          </a:p>
-          <a:p>
-            <a:pPr indent="0" marL="0">
-              <a:spcAft>
-                <a:spcPts val="1400"/>
-              </a:spcAft>
-              <a:buNone/>
-            </a:pPr>
-            <a:r>
-              <a:rPr lang="en-US" sz="1450" dirty="0">
-                <a:solidFill>
-                  <a:srgbClr val="E6F2F4"/>
-                </a:solidFill>
-                <a:latin typeface="Calibri" pitchFamily="34" charset="0"/>
-                <a:ea typeface="Calibri" pitchFamily="34" charset="-122"/>
-                <a:cs typeface="Calibri" pitchFamily="34" charset="-120"/>
-              </a:rPr>
-              <a:t>To find the real knee: remove think-time and push to thousands of VUs (a dedicated stress test).</a:t>
-            </a:r>
-            <a:endParaRPr lang="en-US" sz="1450" dirty="0"/>
-          </a:p>
-          <a:p>
-            <a:pPr indent="0" marL="0">
-              <a:spcAft>
-                <a:spcPts val="1400"/>
-              </a:spcAft>
-              <a:buNone/>
-            </a:pPr>
-            <a:r>
-              <a:rPr lang="en-US" sz="1450" dirty="0">
-                <a:solidFill>
-                  <a:srgbClr val="E6F2F4"/>
-                </a:solidFill>
-                <a:latin typeface="Calibri" pitchFamily="34" charset="0"/>
-                <a:ea typeface="Calibri" pitchFamily="34" charset="-122"/>
-                <a:cs typeface="Calibri" pitchFamily="34" charset="-120"/>
-              </a:rPr>
-              <a:t>Scale it with: caching, multiple instances behind a load balancer, and a CDN for the static JSON.</a:t>
-            </a:r>
-            <a:endParaRPr lang="en-US" sz="1450" dirty="0"/>
           </a:p>
         </p:txBody>
       </p:sp>
@@ -6312,7 +5517,7 @@
                 <a:ea typeface="Calibri" pitchFamily="34" charset="-122"/>
                 <a:cs typeface="Calibri" pitchFamily="34" charset="-120"/>
               </a:rPr>
-              <a:t>What: </a:t>
+              <a:t xml:space="preserve">What: </a:t>
             </a:r>
             <a:pPr indent="0" marL="0">
               <a:buNone/>
@@ -6365,7 +5570,7 @@
                 <a:ea typeface="Calibri" pitchFamily="34" charset="-122"/>
                 <a:cs typeface="Calibri" pitchFamily="34" charset="-120"/>
               </a:rPr>
-              <a:t>Why: </a:t>
+              <a:t xml:space="preserve">Why: </a:t>
             </a:r>
             <a:pPr indent="0" marL="0">
               <a:buNone/>
@@ -6418,7 +5623,7 @@
                 <a:ea typeface="Calibri" pitchFamily="34" charset="-122"/>
                 <a:cs typeface="Calibri" pitchFamily="34" charset="-120"/>
               </a:rPr>
-              <a:t>How: </a:t>
+              <a:t xml:space="preserve">How: </a:t>
             </a:r>
             <a:pPr indent="0" marL="0">
               <a:buNone/>
@@ -6877,7 +6082,7 @@
                 <a:ea typeface="Calibri" pitchFamily="34" charset="-122"/>
                 <a:cs typeface="Calibri" pitchFamily="34" charset="-120"/>
               </a:rPr>
-              <a:t>What: </a:t>
+              <a:t xml:space="preserve">What: </a:t>
             </a:r>
             <a:pPr indent="0" marL="0">
               <a:buNone/>
@@ -6930,7 +6135,7 @@
                 <a:ea typeface="Calibri" pitchFamily="34" charset="-122"/>
                 <a:cs typeface="Calibri" pitchFamily="34" charset="-120"/>
               </a:rPr>
-              <a:t>Why: </a:t>
+              <a:t xml:space="preserve">Why: </a:t>
             </a:r>
             <a:pPr indent="0" marL="0">
               <a:buNone/>
@@ -6983,7 +6188,7 @@
                 <a:ea typeface="Calibri" pitchFamily="34" charset="-122"/>
                 <a:cs typeface="Calibri" pitchFamily="34" charset="-120"/>
               </a:rPr>
-              <a:t>How: </a:t>
+              <a:t xml:space="preserve">How: </a:t>
             </a:r>
             <a:pPr indent="0" marL="0">
               <a:buNone/>
@@ -7421,7 +6626,7 @@
                 <a:ea typeface="Calibri" pitchFamily="34" charset="-122"/>
                 <a:cs typeface="Calibri" pitchFamily="34" charset="-120"/>
               </a:rPr>
-              <a:t>What: </a:t>
+              <a:t xml:space="preserve">What: </a:t>
             </a:r>
             <a:pPr indent="0" marL="0">
               <a:buNone/>
@@ -7474,7 +6679,7 @@
                 <a:ea typeface="Calibri" pitchFamily="34" charset="-122"/>
                 <a:cs typeface="Calibri" pitchFamily="34" charset="-120"/>
               </a:rPr>
-              <a:t>Why: </a:t>
+              <a:t xml:space="preserve">Why: </a:t>
             </a:r>
             <a:pPr indent="0" marL="0">
               <a:buNone/>
@@ -7527,7 +6732,7 @@
                 <a:ea typeface="Calibri" pitchFamily="34" charset="-122"/>
                 <a:cs typeface="Calibri" pitchFamily="34" charset="-120"/>
               </a:rPr>
-              <a:t>How: </a:t>
+              <a:t xml:space="preserve">How: </a:t>
             </a:r>
             <a:pPr indent="0" marL="0">
               <a:buNone/>
@@ -8058,7 +7263,7 @@
                 <a:ea typeface="Calibri" pitchFamily="34" charset="-122"/>
                 <a:cs typeface="Calibri" pitchFamily="34" charset="-120"/>
               </a:rPr>
-              <a:t>backend  </a:t>
+              <a:t xml:space="preserve">backend  </a:t>
             </a:r>
             <a:pPr indent="0" marL="0">
               <a:buNone/>
@@ -8165,7 +7370,7 @@
                 <a:ea typeface="Calibri" pitchFamily="34" charset="-122"/>
                 <a:cs typeface="Calibri" pitchFamily="34" charset="-120"/>
               </a:rPr>
-              <a:t>frontend  </a:t>
+              <a:t xml:space="preserve">frontend  </a:t>
             </a:r>
             <a:pPr indent="0" marL="0">
               <a:buNone/>
@@ -8272,7 +7477,7 @@
                 <a:ea typeface="Calibri" pitchFamily="34" charset="-122"/>
                 <a:cs typeface="Calibri" pitchFamily="34" charset="-120"/>
               </a:rPr>
-              <a:t>playwright  </a:t>
+              <a:t xml:space="preserve">playwright  </a:t>
             </a:r>
             <a:pPr indent="0" marL="0">
               <a:buNone/>
@@ -8993,7 +8198,7 @@
                 <a:ea typeface="Calibri" pitchFamily="34" charset="-122"/>
                 <a:cs typeface="Calibri" pitchFamily="34" charset="-120"/>
               </a:rPr>
-              <a:t>SLO: </a:t>
+              <a:t xml:space="preserve">SLO: </a:t>
             </a:r>
             <a:pPr indent="0" marL="0">
               <a:buNone/>

</xml_diff>